<commit_message>
PMBIPO-490: updated slide.csv files and PRT file slide names to match.
</commit_message>
<xml_diff>
--- a/api/src/program_review_tool/utils/review/export/assets/PRT.pptx
+++ b/api/src/program_review_tool/utils/review/export/assets/PRT.pptx
@@ -244,7 +244,7 @@
           <a:p>
             <a:fld id="{84ED06A4-8F7B-974B-B734-1ED967E82B37}" type="datetimeFigureOut">
               <a:rPr lang="en-US" smtClean="0"/>
-              <a:t>4/2/2025</a:t>
+              <a:t>10/6/2025</a:t>
             </a:fld>
             <a:endParaRPr lang="en-US"/>
           </a:p>
@@ -421,7 +421,7 @@
           <a:p>
             <a:fld id="{209E9AA5-4EBA-7C43-A74A-42DA5466B4F2}" type="datetimeFigureOut">
               <a:rPr lang="en-US" smtClean="0"/>
-              <a:t>4/2/2025</a:t>
+              <a:t>10/6/2025</a:t>
             </a:fld>
             <a:endParaRPr lang="en-US"/>
           </a:p>
@@ -22995,8 +22995,8 @@
           <a:lstStyle/>
           <a:p>
             <a:r>
-              <a:rPr lang="en-US"/>
-              <a:t>Program/Portfolio Summary</a:t>
+              <a:rPr lang="en-US" dirty="0"/>
+              <a:t>Portfolio Summary</a:t>
             </a:r>
           </a:p>
         </p:txBody>
@@ -23056,8 +23056,8 @@
           <a:lstStyle/>
           <a:p>
             <a:r>
-              <a:rPr lang="en-US"/>
-              <a:t>Program/Portfolio Assessment</a:t>
+              <a:rPr lang="en-US" dirty="0"/>
+              <a:t>Portfolio Assessment</a:t>
             </a:r>
           </a:p>
         </p:txBody>

</xml_diff>

<commit_message>
PMBIPO-557: updated PPT template and added venv to gitignore
</commit_message>
<xml_diff>
--- a/api/src/program_review_tool/utils/review/export/assets/PRT.pptx
+++ b/api/src/program_review_tool/utils/review/export/assets/PRT.pptx
@@ -142,12 +142,112 @@
 </p:presentation>
 </file>
 
-<file path=ppt/revisionInfo.xml><?xml version="1.0" encoding="utf-8"?>
-<p1510:revInfo xmlns:a="http://schemas.openxmlformats.org/drawingml/2006/main" xmlns:r="http://schemas.openxmlformats.org/officeDocument/2006/relationships" xmlns:p1510="http://schemas.microsoft.com/office/powerpoint/2015/10/main">
-  <p1510:revLst>
-    <p1510:client id="{C0185FB3-32BF-471F-9F72-E1C33595AEA3}" v="30" dt="2024-09-25T14:24:08.002"/>
-  </p1510:revLst>
-</p1510:revInfo>
+<file path=ppt/changesInfos/changesInfo1.xml><?xml version="1.0" encoding="utf-8"?>
+<pc:chgInfo xmlns:a="http://schemas.openxmlformats.org/drawingml/2006/main" xmlns:r="http://schemas.openxmlformats.org/officeDocument/2006/relationships" xmlns:ac="http://schemas.microsoft.com/office/drawing/2013/main/command" xmlns:pc="http://schemas.microsoft.com/office/powerpoint/2013/main/command">
+  <pc:docChgLst>
+    <pc:chgData name="Charbonneau, Nathaniel (US) - SMS" userId="e356a6b2-cd98-4cf8-9e8a-51b62fe00397" providerId="ADAL" clId="{A9E603A2-D1D5-4773-92E6-3B1AC4455016}"/>
+    <pc:docChg chg="custSel modSld">
+      <pc:chgData name="Charbonneau, Nathaniel (US) - SMS" userId="e356a6b2-cd98-4cf8-9e8a-51b62fe00397" providerId="ADAL" clId="{A9E603A2-D1D5-4773-92E6-3B1AC4455016}" dt="2026-01-08T20:40:34.133" v="43" actId="478"/>
+      <pc:docMkLst>
+        <pc:docMk/>
+      </pc:docMkLst>
+      <pc:sldChg chg="modSp mod">
+        <pc:chgData name="Charbonneau, Nathaniel (US) - SMS" userId="e356a6b2-cd98-4cf8-9e8a-51b62fe00397" providerId="ADAL" clId="{A9E603A2-D1D5-4773-92E6-3B1AC4455016}" dt="2026-01-08T20:29:48.720" v="42" actId="166"/>
+        <pc:sldMkLst>
+          <pc:docMk/>
+          <pc:sldMk cId="3979934098" sldId="257"/>
+        </pc:sldMkLst>
+        <pc:spChg chg="ord">
+          <ac:chgData name="Charbonneau, Nathaniel (US) - SMS" userId="e356a6b2-cd98-4cf8-9e8a-51b62fe00397" providerId="ADAL" clId="{A9E603A2-D1D5-4773-92E6-3B1AC4455016}" dt="2026-01-08T20:29:48.720" v="42" actId="166"/>
+          <ac:spMkLst>
+            <pc:docMk/>
+            <pc:sldMk cId="3979934098" sldId="257"/>
+            <ac:spMk id="5" creationId="{94735E6F-DAB2-353D-A8B1-506E6D9F8F2B}"/>
+          </ac:spMkLst>
+        </pc:spChg>
+        <pc:spChg chg="ord">
+          <ac:chgData name="Charbonneau, Nathaniel (US) - SMS" userId="e356a6b2-cd98-4cf8-9e8a-51b62fe00397" providerId="ADAL" clId="{A9E603A2-D1D5-4773-92E6-3B1AC4455016}" dt="2026-01-08T20:29:48.720" v="42" actId="166"/>
+          <ac:spMkLst>
+            <pc:docMk/>
+            <pc:sldMk cId="3979934098" sldId="257"/>
+            <ac:spMk id="6" creationId="{58202E0C-E1D6-6AF9-A0DF-44E9BE7B4E26}"/>
+          </ac:spMkLst>
+        </pc:spChg>
+        <pc:spChg chg="ord">
+          <ac:chgData name="Charbonneau, Nathaniel (US) - SMS" userId="e356a6b2-cd98-4cf8-9e8a-51b62fe00397" providerId="ADAL" clId="{A9E603A2-D1D5-4773-92E6-3B1AC4455016}" dt="2026-01-08T20:29:48.720" v="42" actId="166"/>
+          <ac:spMkLst>
+            <pc:docMk/>
+            <pc:sldMk cId="3979934098" sldId="257"/>
+            <ac:spMk id="7" creationId="{25B36D4F-C88B-6E29-1F39-499501E4F1B1}"/>
+          </ac:spMkLst>
+        </pc:spChg>
+        <pc:spChg chg="ord">
+          <ac:chgData name="Charbonneau, Nathaniel (US) - SMS" userId="e356a6b2-cd98-4cf8-9e8a-51b62fe00397" providerId="ADAL" clId="{A9E603A2-D1D5-4773-92E6-3B1AC4455016}" dt="2026-01-08T20:29:48.720" v="42" actId="166"/>
+          <ac:spMkLst>
+            <pc:docMk/>
+            <pc:sldMk cId="3979934098" sldId="257"/>
+            <ac:spMk id="8" creationId="{8AA086E3-E087-7079-785B-27D07DB8299C}"/>
+          </ac:spMkLst>
+        </pc:spChg>
+      </pc:sldChg>
+      <pc:sldChg chg="addSp delSp modSp mod">
+        <pc:chgData name="Charbonneau, Nathaniel (US) - SMS" userId="e356a6b2-cd98-4cf8-9e8a-51b62fe00397" providerId="ADAL" clId="{A9E603A2-D1D5-4773-92E6-3B1AC4455016}" dt="2026-01-08T20:40:34.133" v="43" actId="478"/>
+        <pc:sldMkLst>
+          <pc:docMk/>
+          <pc:sldMk cId="3098909055" sldId="259"/>
+        </pc:sldMkLst>
+        <pc:spChg chg="mod">
+          <ac:chgData name="Charbonneau, Nathaniel (US) - SMS" userId="e356a6b2-cd98-4cf8-9e8a-51b62fe00397" providerId="ADAL" clId="{A9E603A2-D1D5-4773-92E6-3B1AC4455016}" dt="2026-01-08T20:21:37.619" v="40" actId="1076"/>
+          <ac:spMkLst>
+            <pc:docMk/>
+            <pc:sldMk cId="3098909055" sldId="259"/>
+            <ac:spMk id="6" creationId="{40304CC2-4811-7A1A-04ED-68AFDF15CF25}"/>
+          </ac:spMkLst>
+        </pc:spChg>
+        <pc:spChg chg="mod">
+          <ac:chgData name="Charbonneau, Nathaniel (US) - SMS" userId="e356a6b2-cd98-4cf8-9e8a-51b62fe00397" providerId="ADAL" clId="{A9E603A2-D1D5-4773-92E6-3B1AC4455016}" dt="2026-01-08T20:21:34.766" v="39" actId="14100"/>
+          <ac:spMkLst>
+            <pc:docMk/>
+            <pc:sldMk cId="3098909055" sldId="259"/>
+            <ac:spMk id="7" creationId="{2CF5CF83-0BAD-8B9C-A422-C8EAF7DE8C3D}"/>
+          </ac:spMkLst>
+        </pc:spChg>
+        <pc:spChg chg="mod">
+          <ac:chgData name="Charbonneau, Nathaniel (US) - SMS" userId="e356a6b2-cd98-4cf8-9e8a-51b62fe00397" providerId="ADAL" clId="{A9E603A2-D1D5-4773-92E6-3B1AC4455016}" dt="2026-01-08T20:21:29.094" v="37" actId="14100"/>
+          <ac:spMkLst>
+            <pc:docMk/>
+            <pc:sldMk cId="3098909055" sldId="259"/>
+            <ac:spMk id="8" creationId="{F4FCCB49-62CD-FA63-B1A5-4F111F4D88CE}"/>
+          </ac:spMkLst>
+        </pc:spChg>
+        <pc:spChg chg="mod">
+          <ac:chgData name="Charbonneau, Nathaniel (US) - SMS" userId="e356a6b2-cd98-4cf8-9e8a-51b62fe00397" providerId="ADAL" clId="{A9E603A2-D1D5-4773-92E6-3B1AC4455016}" dt="2026-01-08T20:21:43.540" v="41" actId="1076"/>
+          <ac:spMkLst>
+            <pc:docMk/>
+            <pc:sldMk cId="3098909055" sldId="259"/>
+            <ac:spMk id="9" creationId="{E77019C0-FDE9-C6EF-13C8-23C2687A1658}"/>
+          </ac:spMkLst>
+        </pc:spChg>
+        <pc:picChg chg="add del mod ord">
+          <ac:chgData name="Charbonneau, Nathaniel (US) - SMS" userId="e356a6b2-cd98-4cf8-9e8a-51b62fe00397" providerId="ADAL" clId="{A9E603A2-D1D5-4773-92E6-3B1AC4455016}" dt="2026-01-08T20:19:39.659" v="5" actId="478"/>
+          <ac:picMkLst>
+            <pc:docMk/>
+            <pc:sldMk cId="3098909055" sldId="259"/>
+            <ac:picMk id="4" creationId="{8AA0D320-2F98-2164-C5FE-93D9000B2CD0}"/>
+          </ac:picMkLst>
+        </pc:picChg>
+        <pc:picChg chg="add del mod ord">
+          <ac:chgData name="Charbonneau, Nathaniel (US) - SMS" userId="e356a6b2-cd98-4cf8-9e8a-51b62fe00397" providerId="ADAL" clId="{A9E603A2-D1D5-4773-92E6-3B1AC4455016}" dt="2026-01-08T20:40:34.133" v="43" actId="478"/>
+          <ac:picMkLst>
+            <pc:docMk/>
+            <pc:sldMk cId="3098909055" sldId="259"/>
+            <ac:picMk id="10" creationId="{BD559DFA-8010-322D-0032-13E5A0E80CA4}"/>
+          </ac:picMkLst>
+        </pc:picChg>
+      </pc:sldChg>
+    </pc:docChg>
+  </pc:docChgLst>
+</pc:chgInfo>
 </file>
 
 <file path=ppt/handoutMasters/handoutMaster1.xml><?xml version="1.0" encoding="utf-8"?>
@@ -244,7 +344,7 @@
           <a:p>
             <a:fld id="{84ED06A4-8F7B-974B-B734-1ED967E82B37}" type="datetimeFigureOut">
               <a:rPr lang="en-US" smtClean="0"/>
-              <a:t>10/6/2025</a:t>
+              <a:t>1/16/2026</a:t>
             </a:fld>
             <a:endParaRPr lang="en-US"/>
           </a:p>
@@ -421,7 +521,7 @@
           <a:p>
             <a:fld id="{209E9AA5-4EBA-7C43-A74A-42DA5466B4F2}" type="datetimeFigureOut">
               <a:rPr lang="en-US" smtClean="0"/>
-              <a:t>10/6/2025</a:t>
+              <a:t>1/16/2026</a:t>
             </a:fld>
             <a:endParaRPr lang="en-US"/>
           </a:p>
@@ -753,10 +853,10 @@
       </p:grpSpPr>
       <p:pic>
         <p:nvPicPr>
-          <p:cNvPr id="3" name="Picture 2">
+          <p:cNvPr id="11" name="Picture 10" descr="A picture containing sky, water, outdoor, sport&#10;&#10;AI-generated content may be incorrect.">
             <a:extLst>
               <a:ext uri="{FF2B5EF4-FFF2-40B4-BE49-F238E27FC236}">
-                <a16:creationId xmlns:a16="http://schemas.microsoft.com/office/drawing/2014/main" id="{2D9CF1AA-360B-F687-5BF1-CFA7E3352460}"/>
+                <a16:creationId xmlns:a16="http://schemas.microsoft.com/office/drawing/2014/main" id="{3E77178F-0BB9-C7B3-D2C4-CDCB964DA96D}"/>
               </a:ext>
             </a:extLst>
           </p:cNvPr>
@@ -766,15 +866,10 @@
           <p:nvPr userDrawn="1"/>
         </p:nvPicPr>
         <p:blipFill>
-          <a:blip r:embed="rId2" cstate="print">
-            <a:extLst>
-              <a:ext uri="{28A0092B-C50C-407E-A947-70E740481C1C}">
-                <a14:useLocalDpi xmlns:a14="http://schemas.microsoft.com/office/drawing/2010/main"/>
-              </a:ext>
-            </a:extLst>
-          </a:blip>
-          <a:srcRect/>
-          <a:stretch/>
+          <a:blip r:embed="rId2"/>
+          <a:stretch>
+            <a:fillRect/>
+          </a:stretch>
         </p:blipFill>
         <p:spPr>
           <a:xfrm>
@@ -1000,7 +1095,7 @@
         </p:nvCxnSpPr>
         <p:spPr>
           <a:xfrm>
-            <a:off x="4572000" y="6319688"/>
+            <a:off x="4572000" y="6247968"/>
             <a:ext cx="4135582" cy="0"/>
           </a:xfrm>
           <a:prstGeom prst="line">
@@ -1008,9 +1103,7 @@
           </a:prstGeom>
           <a:ln w="3175" cap="sq">
             <a:solidFill>
-              <a:schemeClr val="bg1">
-                <a:lumMod val="95000"/>
-              </a:schemeClr>
+              <a:srgbClr val="737373"/>
             </a:solidFill>
           </a:ln>
         </p:spPr>
@@ -1047,9 +1140,12 @@
         </p:nvSpPr>
         <p:spPr>
           <a:xfrm>
-            <a:off x="4586836" y="6360019"/>
+            <a:off x="4572000" y="6123715"/>
             <a:ext cx="4135581" cy="123111"/>
           </a:xfrm>
+          <a:ln>
+            <a:noFill/>
+          </a:ln>
         </p:spPr>
         <p:txBody>
           <a:bodyPr anchor="ctr">
@@ -1064,9 +1160,7 @@
               <a:buNone/>
               <a:defRPr sz="800" b="0">
                 <a:solidFill>
-                  <a:schemeClr val="bg1">
-                    <a:lumMod val="95000"/>
-                  </a:schemeClr>
+                  <a:srgbClr val="172430"/>
                 </a:solidFill>
               </a:defRPr>
             </a:lvl1pPr>
@@ -1392,6 +1486,139 @@
             <a:r>
               <a:rPr lang="en-US" dirty="0"/>
               <a:t> | Presenter Title</a:t>
+            </a:r>
+          </a:p>
+        </p:txBody>
+      </p:sp>
+      <p:sp>
+        <p:nvSpPr>
+          <p:cNvPr id="12" name="Confidential">
+            <a:extLst>
+              <a:ext uri="{FF2B5EF4-FFF2-40B4-BE49-F238E27FC236}">
+                <a16:creationId xmlns:a16="http://schemas.microsoft.com/office/drawing/2014/main" id="{903280AF-84C8-EA2F-AD82-638DD69A116B}"/>
+              </a:ext>
+            </a:extLst>
+          </p:cNvPr>
+          <p:cNvSpPr txBox="1">
+            <a:spLocks/>
+          </p:cNvSpPr>
+          <p:nvPr userDrawn="1"/>
+        </p:nvSpPr>
+        <p:spPr>
+          <a:xfrm>
+            <a:off x="6220852" y="6428117"/>
+            <a:ext cx="2379027" cy="137160"/>
+          </a:xfrm>
+          <a:prstGeom prst="rect">
+            <a:avLst/>
+          </a:prstGeom>
+        </p:spPr>
+        <p:txBody>
+          <a:bodyPr vert="horz" wrap="none" lIns="0" tIns="0" rIns="0" bIns="0" rtlCol="0" anchor="t" anchorCtr="0"/>
+          <a:lstStyle>
+            <a:defPPr>
+              <a:defRPr lang="en-US"/>
+            </a:defPPr>
+            <a:lvl1pPr marL="0" algn="ctr" defTabSz="457200" rtl="0" eaLnBrk="1" latinLnBrk="0" hangingPunct="1">
+              <a:defRPr sz="800" kern="1200">
+                <a:solidFill>
+                  <a:schemeClr val="tx1"/>
+                </a:solidFill>
+                <a:latin typeface="+mn-lt"/>
+                <a:ea typeface="+mn-ea"/>
+                <a:cs typeface="+mn-cs"/>
+              </a:defRPr>
+            </a:lvl1pPr>
+            <a:lvl2pPr marL="457200" algn="l" defTabSz="457200" rtl="0" eaLnBrk="1" latinLnBrk="0" hangingPunct="1">
+              <a:defRPr sz="1800" kern="1200">
+                <a:solidFill>
+                  <a:schemeClr val="tx1"/>
+                </a:solidFill>
+                <a:latin typeface="+mn-lt"/>
+                <a:ea typeface="+mn-ea"/>
+                <a:cs typeface="+mn-cs"/>
+              </a:defRPr>
+            </a:lvl2pPr>
+            <a:lvl3pPr marL="914400" algn="l" defTabSz="457200" rtl="0" eaLnBrk="1" latinLnBrk="0" hangingPunct="1">
+              <a:defRPr sz="1800" kern="1200">
+                <a:solidFill>
+                  <a:schemeClr val="tx1"/>
+                </a:solidFill>
+                <a:latin typeface="+mn-lt"/>
+                <a:ea typeface="+mn-ea"/>
+                <a:cs typeface="+mn-cs"/>
+              </a:defRPr>
+            </a:lvl3pPr>
+            <a:lvl4pPr marL="1371600" algn="l" defTabSz="457200" rtl="0" eaLnBrk="1" latinLnBrk="0" hangingPunct="1">
+              <a:defRPr sz="1800" kern="1200">
+                <a:solidFill>
+                  <a:schemeClr val="tx1"/>
+                </a:solidFill>
+                <a:latin typeface="+mn-lt"/>
+                <a:ea typeface="+mn-ea"/>
+                <a:cs typeface="+mn-cs"/>
+              </a:defRPr>
+            </a:lvl4pPr>
+            <a:lvl5pPr marL="1828800" algn="l" defTabSz="457200" rtl="0" eaLnBrk="1" latinLnBrk="0" hangingPunct="1">
+              <a:defRPr sz="1800" kern="1200">
+                <a:solidFill>
+                  <a:schemeClr val="tx1"/>
+                </a:solidFill>
+                <a:latin typeface="+mn-lt"/>
+                <a:ea typeface="+mn-ea"/>
+                <a:cs typeface="+mn-cs"/>
+              </a:defRPr>
+            </a:lvl5pPr>
+            <a:lvl6pPr marL="2286000" algn="l" defTabSz="457200" rtl="0" eaLnBrk="1" latinLnBrk="0" hangingPunct="1">
+              <a:defRPr sz="1800" kern="1200">
+                <a:solidFill>
+                  <a:schemeClr val="tx1"/>
+                </a:solidFill>
+                <a:latin typeface="+mn-lt"/>
+                <a:ea typeface="+mn-ea"/>
+                <a:cs typeface="+mn-cs"/>
+              </a:defRPr>
+            </a:lvl6pPr>
+            <a:lvl7pPr marL="2743200" algn="l" defTabSz="457200" rtl="0" eaLnBrk="1" latinLnBrk="0" hangingPunct="1">
+              <a:defRPr sz="1800" kern="1200">
+                <a:solidFill>
+                  <a:schemeClr val="tx1"/>
+                </a:solidFill>
+                <a:latin typeface="+mn-lt"/>
+                <a:ea typeface="+mn-ea"/>
+                <a:cs typeface="+mn-cs"/>
+              </a:defRPr>
+            </a:lvl7pPr>
+            <a:lvl8pPr marL="3200400" algn="l" defTabSz="457200" rtl="0" eaLnBrk="1" latinLnBrk="0" hangingPunct="1">
+              <a:defRPr sz="1800" kern="1200">
+                <a:solidFill>
+                  <a:schemeClr val="tx1"/>
+                </a:solidFill>
+                <a:latin typeface="+mn-lt"/>
+                <a:ea typeface="+mn-ea"/>
+                <a:cs typeface="+mn-cs"/>
+              </a:defRPr>
+            </a:lvl8pPr>
+            <a:lvl9pPr marL="3657600" algn="l" defTabSz="457200" rtl="0" eaLnBrk="1" latinLnBrk="0" hangingPunct="1">
+              <a:defRPr sz="1800" kern="1200">
+                <a:solidFill>
+                  <a:schemeClr val="tx1"/>
+                </a:solidFill>
+                <a:latin typeface="+mn-lt"/>
+                <a:ea typeface="+mn-ea"/>
+                <a:cs typeface="+mn-cs"/>
+              </a:defRPr>
+            </a:lvl9pPr>
+          </a:lstStyle>
+          <a:p>
+            <a:pPr algn="r"/>
+            <a:r>
+              <a:rPr lang="en-US" sz="700" b="1" dirty="0">
+                <a:solidFill>
+                  <a:schemeClr val="tx1"/>
+                </a:solidFill>
+              </a:rPr>
+              <a:t>PROPRIETARY INFORMATION</a:t>
             </a:r>
           </a:p>
         </p:txBody>
@@ -22215,7 +22442,7 @@
         </p:nvSpPr>
         <p:spPr>
           <a:xfrm>
-            <a:off x="3251200" y="2692400"/>
+            <a:off x="3251200" y="3179761"/>
             <a:ext cx="5626100" cy="152400"/>
           </a:xfrm>
           <a:prstGeom prst="rect">
@@ -22282,8 +22509,8 @@
         </p:nvSpPr>
         <p:spPr>
           <a:xfrm>
-            <a:off x="3251200" y="2857500"/>
-            <a:ext cx="5626100" cy="1282700"/>
+            <a:off x="3251200" y="3333749"/>
+            <a:ext cx="5626100" cy="1044575"/>
           </a:xfrm>
           <a:prstGeom prst="rect">
             <a:avLst/>
@@ -22330,8 +22557,8 @@
         </p:nvSpPr>
         <p:spPr>
           <a:xfrm>
-            <a:off x="3251200" y="4140200"/>
-            <a:ext cx="5626100" cy="1905000"/>
+            <a:off x="3251200" y="4381500"/>
+            <a:ext cx="5626100" cy="1500746"/>
           </a:xfrm>
           <a:prstGeom prst="rect">
             <a:avLst/>
@@ -22378,7 +22605,7 @@
         </p:nvSpPr>
         <p:spPr>
           <a:xfrm>
-            <a:off x="3251200" y="6045200"/>
+            <a:off x="3251200" y="5882246"/>
             <a:ext cx="5626100" cy="292100"/>
           </a:xfrm>
           <a:prstGeom prst="rect">
@@ -23076,8 +23303,8 @@
         </p:nvSpPr>
         <p:spPr>
           <a:xfrm>
-            <a:off x="3111500" y="1511300"/>
-            <a:ext cx="5778500" cy="152400"/>
+            <a:off x="3239937" y="1841151"/>
+            <a:ext cx="5325135" cy="165857"/>
           </a:xfrm>
           <a:prstGeom prst="rect">
             <a:avLst/>
@@ -23112,7 +23339,7 @@
               <a:buSzPct val="100000"/>
             </a:pPr>
             <a:r>
-              <a:rPr lang="en-US" sz="1000" b="1">
+              <a:rPr lang="en-US" sz="1000" b="1" dirty="0">
                 <a:solidFill>
                   <a:srgbClr val="FFFFFF"/>
                 </a:solidFill>
@@ -23120,12 +23347,6 @@
               </a:rPr>
               <a:t>  Key Messages</a:t>
             </a:r>
-            <a:endParaRPr lang="en-US" sz="1000" b="1" dirty="0">
-              <a:solidFill>
-                <a:srgbClr val="FFFFFF"/>
-              </a:solidFill>
-              <a:latin typeface="Arial" panose="020B0604020202020204" pitchFamily="34" charset="0"/>
-            </a:endParaRPr>
           </a:p>
         </p:txBody>
       </p:sp>
@@ -23143,8 +23364,8 @@
         </p:nvSpPr>
         <p:spPr>
           <a:xfrm>
-            <a:off x="3111500" y="1676400"/>
-            <a:ext cx="5778500" cy="1549400"/>
+            <a:off x="3239938" y="2007008"/>
+            <a:ext cx="5325134" cy="1421992"/>
           </a:xfrm>
           <a:prstGeom prst="rect">
             <a:avLst/>
@@ -23191,8 +23412,8 @@
         </p:nvSpPr>
         <p:spPr>
           <a:xfrm>
-            <a:off x="3111500" y="3225800"/>
-            <a:ext cx="5778500" cy="2324100"/>
+            <a:off x="3239938" y="3429000"/>
+            <a:ext cx="5325134" cy="1984248"/>
           </a:xfrm>
           <a:prstGeom prst="rect">
             <a:avLst/>
@@ -23239,8 +23460,8 @@
         </p:nvSpPr>
         <p:spPr>
           <a:xfrm>
-            <a:off x="3111500" y="5549900"/>
-            <a:ext cx="5778500" cy="457200"/>
+            <a:off x="3239937" y="5413248"/>
+            <a:ext cx="5325134" cy="404908"/>
           </a:xfrm>
           <a:prstGeom prst="rect">
             <a:avLst/>

</xml_diff>

<commit_message>
PMBIPO-607: update slides_config and prt pptx file
</commit_message>
<xml_diff>
--- a/api/src/program_review_tool/utils/review/export/assets/PRT.pptx
+++ b/api/src/program_review_tool/utils/review/export/assets/PRT.pptx
@@ -142,114 +142,6 @@
 </p:presentation>
 </file>
 
-<file path=ppt/changesInfos/changesInfo1.xml><?xml version="1.0" encoding="utf-8"?>
-<pc:chgInfo xmlns:a="http://schemas.openxmlformats.org/drawingml/2006/main" xmlns:r="http://schemas.openxmlformats.org/officeDocument/2006/relationships" xmlns:ac="http://schemas.microsoft.com/office/drawing/2013/main/command" xmlns:pc="http://schemas.microsoft.com/office/powerpoint/2013/main/command">
-  <pc:docChgLst>
-    <pc:chgData name="Charbonneau, Nathaniel (US) - SMS" userId="e356a6b2-cd98-4cf8-9e8a-51b62fe00397" providerId="ADAL" clId="{A9E603A2-D1D5-4773-92E6-3B1AC4455016}"/>
-    <pc:docChg chg="custSel modSld">
-      <pc:chgData name="Charbonneau, Nathaniel (US) - SMS" userId="e356a6b2-cd98-4cf8-9e8a-51b62fe00397" providerId="ADAL" clId="{A9E603A2-D1D5-4773-92E6-3B1AC4455016}" dt="2026-01-08T20:40:34.133" v="43" actId="478"/>
-      <pc:docMkLst>
-        <pc:docMk/>
-      </pc:docMkLst>
-      <pc:sldChg chg="modSp mod">
-        <pc:chgData name="Charbonneau, Nathaniel (US) - SMS" userId="e356a6b2-cd98-4cf8-9e8a-51b62fe00397" providerId="ADAL" clId="{A9E603A2-D1D5-4773-92E6-3B1AC4455016}" dt="2026-01-08T20:29:48.720" v="42" actId="166"/>
-        <pc:sldMkLst>
-          <pc:docMk/>
-          <pc:sldMk cId="3979934098" sldId="257"/>
-        </pc:sldMkLst>
-        <pc:spChg chg="ord">
-          <ac:chgData name="Charbonneau, Nathaniel (US) - SMS" userId="e356a6b2-cd98-4cf8-9e8a-51b62fe00397" providerId="ADAL" clId="{A9E603A2-D1D5-4773-92E6-3B1AC4455016}" dt="2026-01-08T20:29:48.720" v="42" actId="166"/>
-          <ac:spMkLst>
-            <pc:docMk/>
-            <pc:sldMk cId="3979934098" sldId="257"/>
-            <ac:spMk id="5" creationId="{94735E6F-DAB2-353D-A8B1-506E6D9F8F2B}"/>
-          </ac:spMkLst>
-        </pc:spChg>
-        <pc:spChg chg="ord">
-          <ac:chgData name="Charbonneau, Nathaniel (US) - SMS" userId="e356a6b2-cd98-4cf8-9e8a-51b62fe00397" providerId="ADAL" clId="{A9E603A2-D1D5-4773-92E6-3B1AC4455016}" dt="2026-01-08T20:29:48.720" v="42" actId="166"/>
-          <ac:spMkLst>
-            <pc:docMk/>
-            <pc:sldMk cId="3979934098" sldId="257"/>
-            <ac:spMk id="6" creationId="{58202E0C-E1D6-6AF9-A0DF-44E9BE7B4E26}"/>
-          </ac:spMkLst>
-        </pc:spChg>
-        <pc:spChg chg="ord">
-          <ac:chgData name="Charbonneau, Nathaniel (US) - SMS" userId="e356a6b2-cd98-4cf8-9e8a-51b62fe00397" providerId="ADAL" clId="{A9E603A2-D1D5-4773-92E6-3B1AC4455016}" dt="2026-01-08T20:29:48.720" v="42" actId="166"/>
-          <ac:spMkLst>
-            <pc:docMk/>
-            <pc:sldMk cId="3979934098" sldId="257"/>
-            <ac:spMk id="7" creationId="{25B36D4F-C88B-6E29-1F39-499501E4F1B1}"/>
-          </ac:spMkLst>
-        </pc:spChg>
-        <pc:spChg chg="ord">
-          <ac:chgData name="Charbonneau, Nathaniel (US) - SMS" userId="e356a6b2-cd98-4cf8-9e8a-51b62fe00397" providerId="ADAL" clId="{A9E603A2-D1D5-4773-92E6-3B1AC4455016}" dt="2026-01-08T20:29:48.720" v="42" actId="166"/>
-          <ac:spMkLst>
-            <pc:docMk/>
-            <pc:sldMk cId="3979934098" sldId="257"/>
-            <ac:spMk id="8" creationId="{8AA086E3-E087-7079-785B-27D07DB8299C}"/>
-          </ac:spMkLst>
-        </pc:spChg>
-      </pc:sldChg>
-      <pc:sldChg chg="addSp delSp modSp mod">
-        <pc:chgData name="Charbonneau, Nathaniel (US) - SMS" userId="e356a6b2-cd98-4cf8-9e8a-51b62fe00397" providerId="ADAL" clId="{A9E603A2-D1D5-4773-92E6-3B1AC4455016}" dt="2026-01-08T20:40:34.133" v="43" actId="478"/>
-        <pc:sldMkLst>
-          <pc:docMk/>
-          <pc:sldMk cId="3098909055" sldId="259"/>
-        </pc:sldMkLst>
-        <pc:spChg chg="mod">
-          <ac:chgData name="Charbonneau, Nathaniel (US) - SMS" userId="e356a6b2-cd98-4cf8-9e8a-51b62fe00397" providerId="ADAL" clId="{A9E603A2-D1D5-4773-92E6-3B1AC4455016}" dt="2026-01-08T20:21:37.619" v="40" actId="1076"/>
-          <ac:spMkLst>
-            <pc:docMk/>
-            <pc:sldMk cId="3098909055" sldId="259"/>
-            <ac:spMk id="6" creationId="{40304CC2-4811-7A1A-04ED-68AFDF15CF25}"/>
-          </ac:spMkLst>
-        </pc:spChg>
-        <pc:spChg chg="mod">
-          <ac:chgData name="Charbonneau, Nathaniel (US) - SMS" userId="e356a6b2-cd98-4cf8-9e8a-51b62fe00397" providerId="ADAL" clId="{A9E603A2-D1D5-4773-92E6-3B1AC4455016}" dt="2026-01-08T20:21:34.766" v="39" actId="14100"/>
-          <ac:spMkLst>
-            <pc:docMk/>
-            <pc:sldMk cId="3098909055" sldId="259"/>
-            <ac:spMk id="7" creationId="{2CF5CF83-0BAD-8B9C-A422-C8EAF7DE8C3D}"/>
-          </ac:spMkLst>
-        </pc:spChg>
-        <pc:spChg chg="mod">
-          <ac:chgData name="Charbonneau, Nathaniel (US) - SMS" userId="e356a6b2-cd98-4cf8-9e8a-51b62fe00397" providerId="ADAL" clId="{A9E603A2-D1D5-4773-92E6-3B1AC4455016}" dt="2026-01-08T20:21:29.094" v="37" actId="14100"/>
-          <ac:spMkLst>
-            <pc:docMk/>
-            <pc:sldMk cId="3098909055" sldId="259"/>
-            <ac:spMk id="8" creationId="{F4FCCB49-62CD-FA63-B1A5-4F111F4D88CE}"/>
-          </ac:spMkLst>
-        </pc:spChg>
-        <pc:spChg chg="mod">
-          <ac:chgData name="Charbonneau, Nathaniel (US) - SMS" userId="e356a6b2-cd98-4cf8-9e8a-51b62fe00397" providerId="ADAL" clId="{A9E603A2-D1D5-4773-92E6-3B1AC4455016}" dt="2026-01-08T20:21:43.540" v="41" actId="1076"/>
-          <ac:spMkLst>
-            <pc:docMk/>
-            <pc:sldMk cId="3098909055" sldId="259"/>
-            <ac:spMk id="9" creationId="{E77019C0-FDE9-C6EF-13C8-23C2687A1658}"/>
-          </ac:spMkLst>
-        </pc:spChg>
-        <pc:picChg chg="add del mod ord">
-          <ac:chgData name="Charbonneau, Nathaniel (US) - SMS" userId="e356a6b2-cd98-4cf8-9e8a-51b62fe00397" providerId="ADAL" clId="{A9E603A2-D1D5-4773-92E6-3B1AC4455016}" dt="2026-01-08T20:19:39.659" v="5" actId="478"/>
-          <ac:picMkLst>
-            <pc:docMk/>
-            <pc:sldMk cId="3098909055" sldId="259"/>
-            <ac:picMk id="4" creationId="{8AA0D320-2F98-2164-C5FE-93D9000B2CD0}"/>
-          </ac:picMkLst>
-        </pc:picChg>
-        <pc:picChg chg="add del mod ord">
-          <ac:chgData name="Charbonneau, Nathaniel (US) - SMS" userId="e356a6b2-cd98-4cf8-9e8a-51b62fe00397" providerId="ADAL" clId="{A9E603A2-D1D5-4773-92E6-3B1AC4455016}" dt="2026-01-08T20:40:34.133" v="43" actId="478"/>
-          <ac:picMkLst>
-            <pc:docMk/>
-            <pc:sldMk cId="3098909055" sldId="259"/>
-            <ac:picMk id="10" creationId="{BD559DFA-8010-322D-0032-13E5A0E80CA4}"/>
-          </ac:picMkLst>
-        </pc:picChg>
-      </pc:sldChg>
-    </pc:docChg>
-  </pc:docChgLst>
-</pc:chgInfo>
-</file>
-
 <file path=ppt/handoutMasters/handoutMaster1.xml><?xml version="1.0" encoding="utf-8"?>
 <p:handoutMaster xmlns:a="http://schemas.openxmlformats.org/drawingml/2006/main" xmlns:r="http://schemas.openxmlformats.org/officeDocument/2006/relationships" xmlns:p="http://schemas.openxmlformats.org/presentationml/2006/main">
   <p:cSld>
@@ -344,7 +236,7 @@
           <a:p>
             <a:fld id="{84ED06A4-8F7B-974B-B734-1ED967E82B37}" type="datetimeFigureOut">
               <a:rPr lang="en-US" smtClean="0"/>
-              <a:t>2/2/2026</a:t>
+              <a:t>2/10/2026</a:t>
             </a:fld>
             <a:endParaRPr lang="en-US"/>
           </a:p>
@@ -521,7 +413,7 @@
           <a:p>
             <a:fld id="{209E9AA5-4EBA-7C43-A74A-42DA5466B4F2}" type="datetimeFigureOut">
               <a:rPr lang="en-US" smtClean="0"/>
-              <a:t>2/2/2026</a:t>
+              <a:t>2/10/2026</a:t>
             </a:fld>
             <a:endParaRPr lang="en-US"/>
           </a:p>
@@ -1071,8 +963,8 @@
         </p:blipFill>
         <p:spPr>
           <a:xfrm>
-            <a:off x="4586836" y="436425"/>
-            <a:ext cx="2140840" cy="609815"/>
+            <a:off x="429768" y="448056"/>
+            <a:ext cx="1990280" cy="566928"/>
           </a:xfrm>
           <a:prstGeom prst="rect">
             <a:avLst/>
@@ -19576,9 +19468,16 @@
             <p:ph type="ctrTitle"/>
           </p:nvPr>
         </p:nvSpPr>
-        <p:spPr/>
+        <p:spPr>
+          <a:xfrm>
+            <a:off x="5577840" y="1591056"/>
+            <a:ext cx="2140840" cy="609815"/>
+          </a:xfrm>
+        </p:spPr>
         <p:txBody>
-          <a:bodyPr/>
+          <a:bodyPr>
+            <a:normAutofit fontScale="90000"/>
+          </a:bodyPr>
           <a:lstStyle/>
           <a:p>
             <a:r>
@@ -19605,7 +19504,12 @@
             <p:ph type="subTitle" idx="1"/>
           </p:nvPr>
         </p:nvSpPr>
-        <p:spPr/>
+        <p:spPr>
+          <a:xfrm>
+            <a:off x="7214656" y="2543166"/>
+            <a:ext cx="1368730" cy="278421"/>
+          </a:xfrm>
+        </p:spPr>
         <p:txBody>
           <a:bodyPr/>
           <a:lstStyle/>
@@ -19659,7 +19563,12 @@
             <p:ph type="body" sz="quarter" idx="10"/>
           </p:nvPr>
         </p:nvSpPr>
-        <p:spPr/>
+        <p:spPr>
+          <a:xfrm>
+            <a:off x="5577840" y="4526280"/>
+            <a:ext cx="1600201" cy="204139"/>
+          </a:xfrm>
+        </p:spPr>
         <p:txBody>
           <a:bodyPr/>
           <a:lstStyle/>
@@ -19689,19 +19598,417 @@
         </p:nvSpPr>
         <p:spPr>
           <a:xfrm>
-            <a:off x="4586836" y="3721719"/>
-            <a:ext cx="4135581" cy="184666"/>
+            <a:off x="5577841" y="3164903"/>
+            <a:ext cx="3376046" cy="184666"/>
           </a:xfrm>
         </p:spPr>
         <p:txBody>
-          <a:bodyPr/>
+          <a:bodyPr anchor="t"/>
           <a:lstStyle/>
           <a:p>
             <a:r>
-              <a:rPr lang="en-US" dirty="0" err="1"/>
+              <a:rPr lang="en-US" b="0" dirty="0" err="1"/>
               <a:t>program_manager</a:t>
             </a:r>
-            <a:endParaRPr lang="en-US" dirty="0"/>
+            <a:endParaRPr lang="en-US" b="0" dirty="0"/>
+          </a:p>
+        </p:txBody>
+      </p:sp>
+      <p:sp>
+        <p:nvSpPr>
+          <p:cNvPr id="7" name="Subtitle 2">
+            <a:extLst>
+              <a:ext uri="{FF2B5EF4-FFF2-40B4-BE49-F238E27FC236}">
+                <a16:creationId xmlns:a16="http://schemas.microsoft.com/office/drawing/2014/main" id="{C0E3D978-BF61-A112-6535-2AE6C25FB884}"/>
+              </a:ext>
+            </a:extLst>
+          </p:cNvPr>
+          <p:cNvSpPr txBox="1">
+            <a:spLocks/>
+          </p:cNvSpPr>
+          <p:nvPr/>
+        </p:nvSpPr>
+        <p:spPr>
+          <a:xfrm>
+            <a:off x="5577840" y="2542897"/>
+            <a:ext cx="1636816" cy="278421"/>
+          </a:xfrm>
+          <a:prstGeom prst="rect">
+            <a:avLst/>
+          </a:prstGeom>
+        </p:spPr>
+        <p:txBody>
+          <a:bodyPr vert="horz" lIns="0" tIns="0" rIns="0" bIns="0" spcCol="274320" rtlCol="0">
+            <a:normAutofit/>
+          </a:bodyPr>
+          <a:lstStyle>
+            <a:lvl1pPr marL="0" indent="0" algn="l" defTabSz="914400" rtl="0" eaLnBrk="1" latinLnBrk="0" hangingPunct="1">
+              <a:lnSpc>
+                <a:spcPct val="100000"/>
+              </a:lnSpc>
+              <a:spcBef>
+                <a:spcPts val="0"/>
+              </a:spcBef>
+              <a:buFont typeface="Arial" panose="020B0604020202020204" pitchFamily="34" charset="0"/>
+              <a:buNone/>
+              <a:defRPr sz="1400" kern="1200">
+                <a:solidFill>
+                  <a:srgbClr val="000000"/>
+                </a:solidFill>
+                <a:latin typeface="+mn-lt"/>
+                <a:ea typeface="+mn-ea"/>
+                <a:cs typeface="+mn-cs"/>
+              </a:defRPr>
+            </a:lvl1pPr>
+            <a:lvl2pPr marL="0" indent="0" algn="l" defTabSz="914400" rtl="0" eaLnBrk="1" latinLnBrk="0" hangingPunct="1">
+              <a:lnSpc>
+                <a:spcPct val="100000"/>
+              </a:lnSpc>
+              <a:spcBef>
+                <a:spcPts val="0"/>
+              </a:spcBef>
+              <a:buFont typeface="Arial" panose="020B0604020202020204" pitchFamily="34" charset="0"/>
+              <a:buNone/>
+              <a:defRPr sz="1600" kern="1200">
+                <a:solidFill>
+                  <a:schemeClr val="tx1"/>
+                </a:solidFill>
+                <a:latin typeface="+mn-lt"/>
+                <a:ea typeface="+mn-ea"/>
+                <a:cs typeface="+mn-cs"/>
+              </a:defRPr>
+            </a:lvl2pPr>
+            <a:lvl3pPr marL="0" indent="0" algn="l" defTabSz="914400" rtl="0" eaLnBrk="1" latinLnBrk="0" hangingPunct="1">
+              <a:lnSpc>
+                <a:spcPct val="100000"/>
+              </a:lnSpc>
+              <a:spcBef>
+                <a:spcPts val="0"/>
+              </a:spcBef>
+              <a:buFont typeface="Arial" panose="020B0604020202020204" pitchFamily="34" charset="0"/>
+              <a:buNone/>
+              <a:defRPr sz="1600" kern="1200">
+                <a:solidFill>
+                  <a:schemeClr val="tx1"/>
+                </a:solidFill>
+                <a:latin typeface="+mn-lt"/>
+                <a:ea typeface="+mn-ea"/>
+                <a:cs typeface="+mn-cs"/>
+              </a:defRPr>
+            </a:lvl3pPr>
+            <a:lvl4pPr marL="0" indent="0" algn="l" defTabSz="914400" rtl="0" eaLnBrk="1" latinLnBrk="0" hangingPunct="1">
+              <a:lnSpc>
+                <a:spcPct val="100000"/>
+              </a:lnSpc>
+              <a:spcBef>
+                <a:spcPts val="0"/>
+              </a:spcBef>
+              <a:buFont typeface="Arial" panose="020B0604020202020204" pitchFamily="34" charset="0"/>
+              <a:buNone/>
+              <a:defRPr sz="1600" kern="1200">
+                <a:solidFill>
+                  <a:schemeClr val="tx1"/>
+                </a:solidFill>
+                <a:latin typeface="+mn-lt"/>
+                <a:ea typeface="+mn-ea"/>
+                <a:cs typeface="+mn-cs"/>
+              </a:defRPr>
+            </a:lvl4pPr>
+            <a:lvl5pPr marL="0" indent="0" algn="l" defTabSz="914400" rtl="0" eaLnBrk="1" latinLnBrk="0" hangingPunct="1">
+              <a:lnSpc>
+                <a:spcPct val="100000"/>
+              </a:lnSpc>
+              <a:spcBef>
+                <a:spcPts val="0"/>
+              </a:spcBef>
+              <a:buFont typeface="Arial" panose="020B0604020202020204" pitchFamily="34" charset="0"/>
+              <a:buNone/>
+              <a:defRPr sz="1600" kern="1200">
+                <a:solidFill>
+                  <a:schemeClr val="tx1"/>
+                </a:solidFill>
+                <a:latin typeface="+mn-lt"/>
+                <a:ea typeface="+mn-ea"/>
+                <a:cs typeface="+mn-cs"/>
+              </a:defRPr>
+            </a:lvl5pPr>
+            <a:lvl6pPr marL="0" indent="0" algn="l" defTabSz="914400" rtl="0" eaLnBrk="1" latinLnBrk="0" hangingPunct="1">
+              <a:lnSpc>
+                <a:spcPct val="100000"/>
+              </a:lnSpc>
+              <a:spcBef>
+                <a:spcPts val="0"/>
+              </a:spcBef>
+              <a:buFont typeface="Arial" panose="020B0604020202020204" pitchFamily="34" charset="0"/>
+              <a:buNone/>
+              <a:defRPr sz="1600" kern="1200">
+                <a:solidFill>
+                  <a:schemeClr val="tx1"/>
+                </a:solidFill>
+                <a:latin typeface="+mn-lt"/>
+                <a:ea typeface="+mn-ea"/>
+                <a:cs typeface="+mn-cs"/>
+              </a:defRPr>
+            </a:lvl6pPr>
+            <a:lvl7pPr marL="0" indent="0" algn="l" defTabSz="914400" rtl="0" eaLnBrk="1" latinLnBrk="0" hangingPunct="1">
+              <a:lnSpc>
+                <a:spcPct val="100000"/>
+              </a:lnSpc>
+              <a:spcBef>
+                <a:spcPts val="0"/>
+              </a:spcBef>
+              <a:buFont typeface="Arial" panose="020B0604020202020204" pitchFamily="34" charset="0"/>
+              <a:buNone/>
+              <a:defRPr sz="1600" kern="1200">
+                <a:solidFill>
+                  <a:schemeClr val="tx1"/>
+                </a:solidFill>
+                <a:latin typeface="+mn-lt"/>
+                <a:ea typeface="+mn-ea"/>
+                <a:cs typeface="+mn-cs"/>
+              </a:defRPr>
+            </a:lvl7pPr>
+            <a:lvl8pPr marL="0" indent="0" algn="l" defTabSz="914400" rtl="0" eaLnBrk="1" latinLnBrk="0" hangingPunct="1">
+              <a:lnSpc>
+                <a:spcPct val="100000"/>
+              </a:lnSpc>
+              <a:spcBef>
+                <a:spcPts val="0"/>
+              </a:spcBef>
+              <a:buFont typeface="Arial" panose="020B0604020202020204" pitchFamily="34" charset="0"/>
+              <a:buNone/>
+              <a:defRPr sz="1600" kern="1200">
+                <a:solidFill>
+                  <a:schemeClr val="tx1"/>
+                </a:solidFill>
+                <a:latin typeface="+mn-lt"/>
+                <a:ea typeface="+mn-ea"/>
+                <a:cs typeface="+mn-cs"/>
+              </a:defRPr>
+            </a:lvl8pPr>
+            <a:lvl9pPr marL="0" indent="0" algn="l" defTabSz="914400" rtl="0" eaLnBrk="1" latinLnBrk="0" hangingPunct="1">
+              <a:lnSpc>
+                <a:spcPct val="100000"/>
+              </a:lnSpc>
+              <a:spcBef>
+                <a:spcPts val="0"/>
+              </a:spcBef>
+              <a:buFont typeface="Arial" panose="020B0604020202020204" pitchFamily="34" charset="0"/>
+              <a:buNone/>
+              <a:defRPr sz="1600" kern="1200">
+                <a:solidFill>
+                  <a:schemeClr val="tx1"/>
+                </a:solidFill>
+                <a:latin typeface="+mn-lt"/>
+                <a:ea typeface="+mn-ea"/>
+                <a:cs typeface="+mn-cs"/>
+              </a:defRPr>
+            </a:lvl9pPr>
+          </a:lstStyle>
+          <a:p>
+            <a:r>
+              <a:rPr lang="en-US" b="1" dirty="0"/>
+              <a:t>Reporting Period:</a:t>
+            </a:r>
+          </a:p>
+        </p:txBody>
+      </p:sp>
+      <p:sp>
+        <p:nvSpPr>
+          <p:cNvPr id="8" name="Subtitle 2">
+            <a:extLst>
+              <a:ext uri="{FF2B5EF4-FFF2-40B4-BE49-F238E27FC236}">
+                <a16:creationId xmlns:a16="http://schemas.microsoft.com/office/drawing/2014/main" id="{3E773724-CDEC-1D78-DD25-FD8E321C2AB4}"/>
+              </a:ext>
+            </a:extLst>
+          </p:cNvPr>
+          <p:cNvSpPr txBox="1">
+            <a:spLocks/>
+          </p:cNvSpPr>
+          <p:nvPr/>
+        </p:nvSpPr>
+        <p:spPr>
+          <a:xfrm>
+            <a:off x="5577840" y="2853900"/>
+            <a:ext cx="1872197" cy="278421"/>
+          </a:xfrm>
+          <a:prstGeom prst="rect">
+            <a:avLst/>
+          </a:prstGeom>
+        </p:spPr>
+        <p:txBody>
+          <a:bodyPr vert="horz" lIns="0" tIns="0" rIns="0" bIns="0" spcCol="274320" rtlCol="0">
+            <a:normAutofit/>
+          </a:bodyPr>
+          <a:lstStyle>
+            <a:lvl1pPr marL="0" indent="0" algn="l" defTabSz="914400" rtl="0" eaLnBrk="1" latinLnBrk="0" hangingPunct="1">
+              <a:lnSpc>
+                <a:spcPct val="100000"/>
+              </a:lnSpc>
+              <a:spcBef>
+                <a:spcPts val="0"/>
+              </a:spcBef>
+              <a:buFont typeface="Arial" panose="020B0604020202020204" pitchFamily="34" charset="0"/>
+              <a:buNone/>
+              <a:defRPr sz="1400" kern="1200">
+                <a:solidFill>
+                  <a:srgbClr val="000000"/>
+                </a:solidFill>
+                <a:latin typeface="+mn-lt"/>
+                <a:ea typeface="+mn-ea"/>
+                <a:cs typeface="+mn-cs"/>
+              </a:defRPr>
+            </a:lvl1pPr>
+            <a:lvl2pPr marL="0" indent="0" algn="l" defTabSz="914400" rtl="0" eaLnBrk="1" latinLnBrk="0" hangingPunct="1">
+              <a:lnSpc>
+                <a:spcPct val="100000"/>
+              </a:lnSpc>
+              <a:spcBef>
+                <a:spcPts val="0"/>
+              </a:spcBef>
+              <a:buFont typeface="Arial" panose="020B0604020202020204" pitchFamily="34" charset="0"/>
+              <a:buNone/>
+              <a:defRPr sz="1600" kern="1200">
+                <a:solidFill>
+                  <a:schemeClr val="tx1"/>
+                </a:solidFill>
+                <a:latin typeface="+mn-lt"/>
+                <a:ea typeface="+mn-ea"/>
+                <a:cs typeface="+mn-cs"/>
+              </a:defRPr>
+            </a:lvl2pPr>
+            <a:lvl3pPr marL="0" indent="0" algn="l" defTabSz="914400" rtl="0" eaLnBrk="1" latinLnBrk="0" hangingPunct="1">
+              <a:lnSpc>
+                <a:spcPct val="100000"/>
+              </a:lnSpc>
+              <a:spcBef>
+                <a:spcPts val="0"/>
+              </a:spcBef>
+              <a:buFont typeface="Arial" panose="020B0604020202020204" pitchFamily="34" charset="0"/>
+              <a:buNone/>
+              <a:defRPr sz="1600" kern="1200">
+                <a:solidFill>
+                  <a:schemeClr val="tx1"/>
+                </a:solidFill>
+                <a:latin typeface="+mn-lt"/>
+                <a:ea typeface="+mn-ea"/>
+                <a:cs typeface="+mn-cs"/>
+              </a:defRPr>
+            </a:lvl3pPr>
+            <a:lvl4pPr marL="0" indent="0" algn="l" defTabSz="914400" rtl="0" eaLnBrk="1" latinLnBrk="0" hangingPunct="1">
+              <a:lnSpc>
+                <a:spcPct val="100000"/>
+              </a:lnSpc>
+              <a:spcBef>
+                <a:spcPts val="0"/>
+              </a:spcBef>
+              <a:buFont typeface="Arial" panose="020B0604020202020204" pitchFamily="34" charset="0"/>
+              <a:buNone/>
+              <a:defRPr sz="1600" kern="1200">
+                <a:solidFill>
+                  <a:schemeClr val="tx1"/>
+                </a:solidFill>
+                <a:latin typeface="+mn-lt"/>
+                <a:ea typeface="+mn-ea"/>
+                <a:cs typeface="+mn-cs"/>
+              </a:defRPr>
+            </a:lvl4pPr>
+            <a:lvl5pPr marL="0" indent="0" algn="l" defTabSz="914400" rtl="0" eaLnBrk="1" latinLnBrk="0" hangingPunct="1">
+              <a:lnSpc>
+                <a:spcPct val="100000"/>
+              </a:lnSpc>
+              <a:spcBef>
+                <a:spcPts val="0"/>
+              </a:spcBef>
+              <a:buFont typeface="Arial" panose="020B0604020202020204" pitchFamily="34" charset="0"/>
+              <a:buNone/>
+              <a:defRPr sz="1600" kern="1200">
+                <a:solidFill>
+                  <a:schemeClr val="tx1"/>
+                </a:solidFill>
+                <a:latin typeface="+mn-lt"/>
+                <a:ea typeface="+mn-ea"/>
+                <a:cs typeface="+mn-cs"/>
+              </a:defRPr>
+            </a:lvl5pPr>
+            <a:lvl6pPr marL="0" indent="0" algn="l" defTabSz="914400" rtl="0" eaLnBrk="1" latinLnBrk="0" hangingPunct="1">
+              <a:lnSpc>
+                <a:spcPct val="100000"/>
+              </a:lnSpc>
+              <a:spcBef>
+                <a:spcPts val="0"/>
+              </a:spcBef>
+              <a:buFont typeface="Arial" panose="020B0604020202020204" pitchFamily="34" charset="0"/>
+              <a:buNone/>
+              <a:defRPr sz="1600" kern="1200">
+                <a:solidFill>
+                  <a:schemeClr val="tx1"/>
+                </a:solidFill>
+                <a:latin typeface="+mn-lt"/>
+                <a:ea typeface="+mn-ea"/>
+                <a:cs typeface="+mn-cs"/>
+              </a:defRPr>
+            </a:lvl6pPr>
+            <a:lvl7pPr marL="0" indent="0" algn="l" defTabSz="914400" rtl="0" eaLnBrk="1" latinLnBrk="0" hangingPunct="1">
+              <a:lnSpc>
+                <a:spcPct val="100000"/>
+              </a:lnSpc>
+              <a:spcBef>
+                <a:spcPts val="0"/>
+              </a:spcBef>
+              <a:buFont typeface="Arial" panose="020B0604020202020204" pitchFamily="34" charset="0"/>
+              <a:buNone/>
+              <a:defRPr sz="1600" kern="1200">
+                <a:solidFill>
+                  <a:schemeClr val="tx1"/>
+                </a:solidFill>
+                <a:latin typeface="+mn-lt"/>
+                <a:ea typeface="+mn-ea"/>
+                <a:cs typeface="+mn-cs"/>
+              </a:defRPr>
+            </a:lvl7pPr>
+            <a:lvl8pPr marL="0" indent="0" algn="l" defTabSz="914400" rtl="0" eaLnBrk="1" latinLnBrk="0" hangingPunct="1">
+              <a:lnSpc>
+                <a:spcPct val="100000"/>
+              </a:lnSpc>
+              <a:spcBef>
+                <a:spcPts val="0"/>
+              </a:spcBef>
+              <a:buFont typeface="Arial" panose="020B0604020202020204" pitchFamily="34" charset="0"/>
+              <a:buNone/>
+              <a:defRPr sz="1600" kern="1200">
+                <a:solidFill>
+                  <a:schemeClr val="tx1"/>
+                </a:solidFill>
+                <a:latin typeface="+mn-lt"/>
+                <a:ea typeface="+mn-ea"/>
+                <a:cs typeface="+mn-cs"/>
+              </a:defRPr>
+            </a:lvl8pPr>
+            <a:lvl9pPr marL="0" indent="0" algn="l" defTabSz="914400" rtl="0" eaLnBrk="1" latinLnBrk="0" hangingPunct="1">
+              <a:lnSpc>
+                <a:spcPct val="100000"/>
+              </a:lnSpc>
+              <a:spcBef>
+                <a:spcPts val="0"/>
+              </a:spcBef>
+              <a:buFont typeface="Arial" panose="020B0604020202020204" pitchFamily="34" charset="0"/>
+              <a:buNone/>
+              <a:defRPr sz="1600" kern="1200">
+                <a:solidFill>
+                  <a:schemeClr val="tx1"/>
+                </a:solidFill>
+                <a:latin typeface="+mn-lt"/>
+                <a:ea typeface="+mn-ea"/>
+                <a:cs typeface="+mn-cs"/>
+              </a:defRPr>
+            </a:lvl9pPr>
+          </a:lstStyle>
+          <a:p>
+            <a:r>
+              <a:rPr lang="en-US" b="1" dirty="0"/>
+              <a:t>Program Manager(s):</a:t>
+            </a:r>
           </a:p>
         </p:txBody>
       </p:sp>

</xml_diff>